<commit_message>
ASI: figuras de la presentacion recompuestas en 16:9 nativo
Las cinco laminas del Anexo II son A3 apaisado (1,22 a 1,65 a 1). En una
diapositiva 16:9 entraban limitadas por la altura y dejaban hasta un 35% del
ancho en blanco: se veian chicas. figs16x9.py las recompone sobre 1920x1080
nativo, separando el dibujo de su chrome, escalandolo para llenar el lienzo y
rearmando titulo, bajada y referencias como riel lateral. Ninguna informacion
se saca: se reubica, y los cuerpos tipograficos suben entre 6% y 34%.

- Gantt e histograma comparten PPD reajustado, como afirma el documento
- los hitos del Gantt pasan de verticales colgando del eje a horizontales
  escalonados: la columna de texto no entraba a lo alto en 16:9
- las referencias en tira horizontal se pasan a lista vertical
- las cinco laminas de figura del deck van ahora a sangre
- la 18 pasa a histograma completo; el aplanamiento se reubica en la 15

Co-Authored-By: Claude Opus 5 <noreply@anthropic.com>
</commit_message>
<xml_diff>
--- a/materias/ASI/entregables/etapa3-presentacion.pptx
+++ b/materias/ASI/entregables/etapa3-presentacion.pptx
@@ -1320,7 +1320,9 @@
           <a:p>
             <a:r>
               <a:rPr lang="en-US" dirty="0"/>
-              <a:t>Lurati. Punto 10. En el histograma, las barras celestes claras son los picos de dos personas: son exactamente las ventanas que motivaron el refuerzo de EI y QA. La línea de puntos es la dotación asignada, y no se supera ningún día. Sumar un segundo referente de operaciones solo bajaría a 189 días: no justifica una tercera incorporación.</a:t>
+              <a:t>Lurati. Punto 10, figura 2.b del Anexo II. Mismo eje de tiempo y misma escala que el Gantt.
+Las barras celestes claras son los picos de dos personas: son exactamente las seis ventanas de sobreasignación que motivaron el refuerzo de EI y QA, y la comparación de estrategias está en la lámina 15. La línea de puntos es la dotación asignada, y no se supera ningún día.
+Si preguntan por qué no un tercer refuerzo: sumar un segundo referente de operaciones solo bajaría de 192 a 189 días, mejora que no justifica una tercera incorporación.</a:t>
             </a:r>
             <a:endParaRPr lang="en-US" dirty="0"/>
           </a:p>
@@ -4167,7 +4169,7 @@
       </p:grpSpPr>
       <p:pic>
         <p:nvPicPr>
-          <p:cNvPr id="2" name="Image 0" descr="/private/tmp/claude-501/-Users-juanbonadeo-Desktop-UTN/8155766a-ead1-4642-9abc-dd512f5585d8/scratchpad/figs/fig3-plano.png">    </p:cNvPr>
+          <p:cNvPr id="2" name="Image 0" descr="/Users/juanbonadeo/Desktop/UTN/materias/ASI/figs/presentacion/fig3-plano.png">    </p:cNvPr>
           <p:cNvPicPr>
             <a:picLocks noChangeAspect="1"/>
           </p:cNvPicPr>
@@ -4181,8 +4183,8 @@
         </p:blipFill>
         <p:spPr>
           <a:xfrm>
-            <a:off x="2135276" y="173736"/>
-            <a:ext cx="7921142" cy="6510528"/>
+            <a:off x="0" y="0"/>
+            <a:ext cx="12191695" cy="6858000"/>
           </a:xfrm>
           <a:prstGeom prst="rect">
             <a:avLst/>
@@ -4223,7 +4225,7 @@
       </p:grpSpPr>
       <p:pic>
         <p:nvPicPr>
-          <p:cNvPr id="2" name="Image 0" descr="/private/tmp/claude-501/-Users-juanbonadeo-Desktop-UTN/8155766a-ead1-4642-9abc-dd512f5585d8/scratchpad/figs/fig4-campo.png">    </p:cNvPr>
+          <p:cNvPr id="2" name="Image 0" descr="/Users/juanbonadeo/Desktop/UTN/materias/ASI/figs/presentacion/fig4-campo.png">    </p:cNvPr>
           <p:cNvPicPr>
             <a:picLocks noChangeAspect="1"/>
           </p:cNvPicPr>
@@ -4237,8 +4239,8 @@
         </p:blipFill>
         <p:spPr>
           <a:xfrm>
-            <a:off x="1268126" y="173736"/>
-            <a:ext cx="9655444" cy="6510528"/>
+            <a:off x="0" y="0"/>
+            <a:ext cx="12191695" cy="6858000"/>
           </a:xfrm>
           <a:prstGeom prst="rect">
             <a:avLst/>
@@ -8554,8 +8556,8 @@
         </p:nvSpPr>
         <p:spPr>
           <a:xfrm>
-            <a:off x="841248" y="4041648"/>
-            <a:ext cx="4843120" cy="2286000"/>
+            <a:off x="841248" y="4023360"/>
+            <a:ext cx="4843120" cy="2331720"/>
           </a:xfrm>
           <a:prstGeom prst="rect">
             <a:avLst/>
@@ -8569,13 +8571,13 @@
           <a:p>
             <a:pPr marL="342900" indent="-342900">
               <a:spcAft>
-                <a:spcPts val="1100"/>
+                <a:spcPts val="800"/>
               </a:spcAft>
               <a:buSzPct val="100000"/>
               <a:buChar char="•"/>
             </a:pPr>
             <a:r>
-              <a:rPr lang="en-US" sz="1250" dirty="0">
+              <a:rPr lang="en-US" sz="1200" dirty="0">
                 <a:solidFill>
                   <a:srgbClr val="2A3B4D"/>
                 </a:solidFill>
@@ -8585,18 +8587,18 @@
               </a:rPr>
               <a:t>Arranque y relevamiento</a:t>
             </a:r>
-            <a:endParaRPr lang="en-US" sz="1250" dirty="0"/>
+            <a:endParaRPr lang="en-US" sz="1200" dirty="0"/>
           </a:p>
           <a:p>
             <a:pPr marL="342900" indent="-342900">
               <a:spcAft>
-                <a:spcPts val="1100"/>
+                <a:spcPts val="800"/>
               </a:spcAft>
               <a:buSzPct val="100000"/>
               <a:buChar char="•"/>
             </a:pPr>
             <a:r>
-              <a:rPr lang="en-US" sz="1250" dirty="0">
+              <a:rPr lang="en-US" sz="1200" dirty="0">
                 <a:solidFill>
                   <a:srgbClr val="2A3B4D"/>
                 </a:solidFill>
@@ -8606,18 +8608,18 @@
               </a:rPr>
               <a:t>Selección del proveedor — 31 días hábiles consecutivos, el tramo más largo y menos comprimible: depende de plazos de mercado y de la firma del contrato</a:t>
             </a:r>
-            <a:endParaRPr lang="en-US" sz="1250" dirty="0"/>
+            <a:endParaRPr lang="en-US" sz="1200" dirty="0"/>
           </a:p>
           <a:p>
             <a:pPr marL="342900" indent="-342900">
               <a:spcAft>
-                <a:spcPts val="1100"/>
+                <a:spcPts val="800"/>
               </a:spcAft>
               <a:buSzPct val="100000"/>
               <a:buChar char="•"/>
             </a:pPr>
             <a:r>
-              <a:rPr lang="en-US" sz="1250" dirty="0">
+              <a:rPr lang="en-US" sz="1200" dirty="0">
                 <a:solidFill>
                   <a:srgbClr val="2A3B4D"/>
                 </a:solidFill>
@@ -8627,18 +8629,18 @@
               </a:rPr>
               <a:t>Las cuatro integraciones encadenadas sobre un mismo especialista</a:t>
             </a:r>
-            <a:endParaRPr lang="en-US" sz="1250" dirty="0"/>
+            <a:endParaRPr lang="en-US" sz="1200" dirty="0"/>
           </a:p>
           <a:p>
             <a:pPr marL="342900" indent="-342900">
               <a:spcAft>
-                <a:spcPts val="1100"/>
+                <a:spcPts val="800"/>
               </a:spcAft>
               <a:buSzPct val="100000"/>
               <a:buChar char="•"/>
             </a:pPr>
             <a:r>
-              <a:rPr lang="en-US" sz="1250" dirty="0">
+              <a:rPr lang="en-US" sz="1200" dirty="0">
                 <a:solidFill>
                   <a:srgbClr val="2A3B4D"/>
                 </a:solidFill>
@@ -8648,7 +8650,28 @@
               </a:rPr>
               <a:t>Pruebas, piloto, capacitación de gestión, tres olas de despliegue y estabilización</a:t>
             </a:r>
-            <a:endParaRPr lang="en-US" sz="1250" dirty="0"/>
+            <a:endParaRPr lang="en-US" sz="1200" dirty="0"/>
+          </a:p>
+          <a:p>
+            <a:pPr marL="342900" indent="-342900">
+              <a:spcAft>
+                <a:spcPts val="800"/>
+              </a:spcAft>
+              <a:buSzPct val="100000"/>
+              <a:buChar char="•"/>
+            </a:pPr>
+            <a:r>
+              <a:rPr lang="en-US" sz="1200" dirty="0">
+                <a:solidFill>
+                  <a:srgbClr val="2A3B4D"/>
+                </a:solidFill>
+                <a:latin typeface="Calibri" pitchFamily="34" charset="0"/>
+                <a:ea typeface="Calibri" pitchFamily="34" charset="-122"/>
+                <a:cs typeface="Calibri" pitchFamily="34" charset="-120"/>
+              </a:rPr>
+              <a:t>Las otras 20 actividades tienen holgura, entre 1 y 84 días hábiles: corriendo 24 de ellas dentro de esa holgura se resuelven los conflictos que el refuerzo no elimina</a:t>
+            </a:r>
+            <a:endParaRPr lang="en-US" sz="1200" dirty="0"/>
           </a:p>
         </p:txBody>
       </p:sp>
@@ -8712,7 +8735,7 @@
                 <a:ea typeface="Calibri" pitchFamily="34" charset="-122"/>
                 <a:cs typeface="Calibri" pitchFamily="34" charset="-120"/>
               </a:rPr>
-              <a:t>LAS 20 ACTIVIDADES CON HOLGURA</a:t>
+              <a:t>APLANAMIENTO DE RECURSOS</a:t>
             </a:r>
             <a:endParaRPr lang="en-US" sz="1150" dirty="0"/>
           </a:p>
@@ -8726,8 +8749,359 @@
         </p:nvSpPr>
         <p:spPr>
           <a:xfrm>
-            <a:off x="6507328" y="4041648"/>
-            <a:ext cx="4843120" cy="1051560"/>
+            <a:off x="6507328" y="4005072"/>
+            <a:ext cx="3517240" cy="347472"/>
+          </a:xfrm>
+          <a:prstGeom prst="rect">
+            <a:avLst/>
+          </a:prstGeom>
+          <a:noFill/>
+          <a:ln/>
+        </p:spPr>
+        <p:txBody>
+          <a:bodyPr wrap="square" lIns="0" tIns="0" rIns="0" bIns="0" rtlCol="0" anchor="ctr"/>
+          <a:lstStyle/>
+          <a:p>
+            <a:pPr indent="0" marL="0">
+              <a:buNone/>
+            </a:pPr>
+            <a:r>
+              <a:rPr lang="en-US" sz="1200" dirty="0">
+                <a:solidFill>
+                  <a:srgbClr val="15406B"/>
+                </a:solidFill>
+                <a:latin typeface="Calibri" pitchFamily="34" charset="0"/>
+                <a:ea typeface="Calibri" pitchFamily="34" charset="-122"/>
+                <a:cs typeface="Calibri" pitchFamily="34" charset="-120"/>
+              </a:rPr>
+              <a:t>CPM a fechas tempranas</a:t>
+            </a:r>
+            <a:endParaRPr lang="en-US" sz="1200" dirty="0"/>
+          </a:p>
+        </p:txBody>
+      </p:sp>
+      <p:sp>
+        <p:nvSpPr>
+          <p:cNvPr id="24" name="Text 22"/>
+          <p:cNvSpPr txBox="1"/>
+          <p:nvPr/>
+        </p:nvSpPr>
+        <p:spPr>
+          <a:xfrm>
+            <a:off x="10051999" y="4005072"/>
+            <a:ext cx="1298448" cy="347472"/>
+          </a:xfrm>
+          <a:prstGeom prst="rect">
+            <a:avLst/>
+          </a:prstGeom>
+          <a:noFill/>
+          <a:ln/>
+        </p:spPr>
+        <p:txBody>
+          <a:bodyPr wrap="square" lIns="0" tIns="0" rIns="0" bIns="0" rtlCol="0" anchor="ctr"/>
+          <a:lstStyle/>
+          <a:p>
+            <a:pPr algn="r" indent="0" marL="0">
+              <a:buNone/>
+            </a:pPr>
+            <a:r>
+              <a:rPr lang="en-US" sz="1600" b="1" dirty="0">
+                <a:solidFill>
+                  <a:srgbClr val="4C6480"/>
+                </a:solidFill>
+                <a:latin typeface="Calibri" pitchFamily="34" charset="0"/>
+                <a:ea typeface="Calibri" pitchFamily="34" charset="-122"/>
+                <a:cs typeface="Calibri" pitchFamily="34" charset="-120"/>
+              </a:rPr>
+              <a:t>187 días</a:t>
+            </a:r>
+            <a:endParaRPr lang="en-US" sz="1600" dirty="0"/>
+          </a:p>
+        </p:txBody>
+      </p:sp>
+      <p:sp>
+        <p:nvSpPr>
+          <p:cNvPr id="25" name="Text 23"/>
+          <p:cNvSpPr txBox="1"/>
+          <p:nvPr/>
+        </p:nvSpPr>
+        <p:spPr>
+          <a:xfrm>
+            <a:off x="6507328" y="4315968"/>
+            <a:ext cx="4843120" cy="256032"/>
+          </a:xfrm>
+          <a:prstGeom prst="rect">
+            <a:avLst/>
+          </a:prstGeom>
+          <a:noFill/>
+          <a:ln/>
+        </p:spPr>
+        <p:txBody>
+          <a:bodyPr wrap="square" lIns="0" tIns="0" rIns="0" bIns="0" rtlCol="0" anchor="ctr"/>
+          <a:lstStyle/>
+          <a:p>
+            <a:pPr indent="0" marL="0">
+              <a:buNone/>
+            </a:pPr>
+            <a:r>
+              <a:rPr lang="en-US" sz="1050" dirty="0">
+                <a:solidFill>
+                  <a:srgbClr val="4C6480"/>
+                </a:solidFill>
+                <a:latin typeface="Calibri" pitchFamily="34" charset="0"/>
+                <a:ea typeface="Calibri" pitchFamily="34" charset="-122"/>
+                <a:cs typeface="Calibri" pitchFamily="34" charset="-120"/>
+              </a:rPr>
+              <a:t>recursos ilimitados · no ejecutable</a:t>
+            </a:r>
+            <a:endParaRPr lang="en-US" sz="1050" dirty="0"/>
+          </a:p>
+        </p:txBody>
+      </p:sp>
+      <p:sp>
+        <p:nvSpPr>
+          <p:cNvPr id="26" name="Text 24"/>
+          <p:cNvSpPr txBox="1"/>
+          <p:nvPr/>
+        </p:nvSpPr>
+        <p:spPr>
+          <a:xfrm>
+            <a:off x="6507328" y="4590288"/>
+            <a:ext cx="3517240" cy="347472"/>
+          </a:xfrm>
+          <a:prstGeom prst="rect">
+            <a:avLst/>
+          </a:prstGeom>
+          <a:noFill/>
+          <a:ln/>
+        </p:spPr>
+        <p:txBody>
+          <a:bodyPr wrap="square" lIns="0" tIns="0" rIns="0" bIns="0" rtlCol="0" anchor="ctr"/>
+          <a:lstStyle/>
+          <a:p>
+            <a:pPr indent="0" marL="0">
+              <a:buNone/>
+            </a:pPr>
+            <a:r>
+              <a:rPr lang="en-US" sz="1200" dirty="0">
+                <a:solidFill>
+                  <a:srgbClr val="15406B"/>
+                </a:solidFill>
+                <a:latin typeface="Calibri" pitchFamily="34" charset="0"/>
+                <a:ea typeface="Calibri" pitchFamily="34" charset="-122"/>
+                <a:cs typeface="Calibri" pitchFamily="34" charset="-120"/>
+              </a:rPr>
+              <a:t>(a) Nivelación pura, una persona por perfil</a:t>
+            </a:r>
+            <a:endParaRPr lang="en-US" sz="1200" dirty="0"/>
+          </a:p>
+        </p:txBody>
+      </p:sp>
+      <p:sp>
+        <p:nvSpPr>
+          <p:cNvPr id="27" name="Text 25"/>
+          <p:cNvSpPr txBox="1"/>
+          <p:nvPr/>
+        </p:nvSpPr>
+        <p:spPr>
+          <a:xfrm>
+            <a:off x="10051999" y="4590288"/>
+            <a:ext cx="1298448" cy="347472"/>
+          </a:xfrm>
+          <a:prstGeom prst="rect">
+            <a:avLst/>
+          </a:prstGeom>
+          <a:noFill/>
+          <a:ln/>
+        </p:spPr>
+        <p:txBody>
+          <a:bodyPr wrap="square" lIns="0" tIns="0" rIns="0" bIns="0" rtlCol="0" anchor="ctr"/>
+          <a:lstStyle/>
+          <a:p>
+            <a:pPr algn="r" indent="0" marL="0">
+              <a:buNone/>
+            </a:pPr>
+            <a:r>
+              <a:rPr lang="en-US" sz="1600" b="1" dirty="0">
+                <a:solidFill>
+                  <a:srgbClr val="4C6480"/>
+                </a:solidFill>
+                <a:latin typeface="Calibri" pitchFamily="34" charset="0"/>
+                <a:ea typeface="Calibri" pitchFamily="34" charset="-122"/>
+                <a:cs typeface="Calibri" pitchFamily="34" charset="-120"/>
+              </a:rPr>
+              <a:t>215 días</a:t>
+            </a:r>
+            <a:endParaRPr lang="en-US" sz="1600" dirty="0"/>
+          </a:p>
+        </p:txBody>
+      </p:sp>
+      <p:sp>
+        <p:nvSpPr>
+          <p:cNvPr id="28" name="Text 26"/>
+          <p:cNvSpPr txBox="1"/>
+          <p:nvPr/>
+        </p:nvSpPr>
+        <p:spPr>
+          <a:xfrm>
+            <a:off x="6507328" y="4901184"/>
+            <a:ext cx="4843120" cy="256032"/>
+          </a:xfrm>
+          <a:prstGeom prst="rect">
+            <a:avLst/>
+          </a:prstGeom>
+          <a:noFill/>
+          <a:ln/>
+        </p:spPr>
+        <p:txBody>
+          <a:bodyPr wrap="square" lIns="0" tIns="0" rIns="0" bIns="0" rtlCol="0" anchor="ctr"/>
+          <a:lstStyle/>
+          <a:p>
+            <a:pPr indent="0" marL="0">
+              <a:buNone/>
+            </a:pPr>
+            <a:r>
+              <a:rPr lang="en-US" sz="1050" dirty="0">
+                <a:solidFill>
+                  <a:srgbClr val="4C6480"/>
+                </a:solidFill>
+                <a:latin typeface="Calibri" pitchFamily="34" charset="0"/>
+                <a:ea typeface="Calibri" pitchFamily="34" charset="-122"/>
+                <a:cs typeface="Calibri" pitchFamily="34" charset="-120"/>
+              </a:rPr>
+              <a:t>+28 días (+15%) · 9 personas</a:t>
+            </a:r>
+            <a:endParaRPr lang="en-US" sz="1050" dirty="0"/>
+          </a:p>
+        </p:txBody>
+      </p:sp>
+      <p:sp>
+        <p:nvSpPr>
+          <p:cNvPr id="29" name="Text 27"/>
+          <p:cNvSpPr txBox="1"/>
+          <p:nvPr/>
+        </p:nvSpPr>
+        <p:spPr>
+          <a:xfrm>
+            <a:off x="6507328" y="5175504"/>
+            <a:ext cx="3517240" cy="347472"/>
+          </a:xfrm>
+          <a:prstGeom prst="rect">
+            <a:avLst/>
+          </a:prstGeom>
+          <a:noFill/>
+          <a:ln/>
+        </p:spPr>
+        <p:txBody>
+          <a:bodyPr wrap="square" lIns="0" tIns="0" rIns="0" bIns="0" rtlCol="0" anchor="ctr"/>
+          <a:lstStyle/>
+          <a:p>
+            <a:pPr indent="0" marL="0">
+              <a:buNone/>
+            </a:pPr>
+            <a:r>
+              <a:rPr lang="en-US" sz="1200" b="1" dirty="0">
+                <a:solidFill>
+                  <a:srgbClr val="15406B"/>
+                </a:solidFill>
+                <a:latin typeface="Calibri" pitchFamily="34" charset="0"/>
+                <a:ea typeface="Calibri" pitchFamily="34" charset="-122"/>
+                <a:cs typeface="Calibri" pitchFamily="34" charset="-120"/>
+              </a:rPr>
+              <a:t>(b) Refuerzo de EI y QA con una persona parcial</a:t>
+            </a:r>
+            <a:endParaRPr lang="en-US" sz="1200" dirty="0"/>
+          </a:p>
+        </p:txBody>
+      </p:sp>
+      <p:sp>
+        <p:nvSpPr>
+          <p:cNvPr id="30" name="Text 28"/>
+          <p:cNvSpPr txBox="1"/>
+          <p:nvPr/>
+        </p:nvSpPr>
+        <p:spPr>
+          <a:xfrm>
+            <a:off x="10051999" y="5175504"/>
+            <a:ext cx="1298448" cy="347472"/>
+          </a:xfrm>
+          <a:prstGeom prst="rect">
+            <a:avLst/>
+          </a:prstGeom>
+          <a:noFill/>
+          <a:ln/>
+        </p:spPr>
+        <p:txBody>
+          <a:bodyPr wrap="square" lIns="0" tIns="0" rIns="0" bIns="0" rtlCol="0" anchor="ctr"/>
+          <a:lstStyle/>
+          <a:p>
+            <a:pPr algn="r" indent="0" marL="0">
+              <a:buNone/>
+            </a:pPr>
+            <a:r>
+              <a:rPr lang="en-US" sz="1600" b="1" dirty="0">
+                <a:solidFill>
+                  <a:srgbClr val="B23A2E"/>
+                </a:solidFill>
+                <a:latin typeface="Calibri" pitchFamily="34" charset="0"/>
+                <a:ea typeface="Calibri" pitchFamily="34" charset="-122"/>
+                <a:cs typeface="Calibri" pitchFamily="34" charset="-120"/>
+              </a:rPr>
+              <a:t>192 días</a:t>
+            </a:r>
+            <a:endParaRPr lang="en-US" sz="1600" dirty="0"/>
+          </a:p>
+        </p:txBody>
+      </p:sp>
+      <p:sp>
+        <p:nvSpPr>
+          <p:cNvPr id="31" name="Text 29"/>
+          <p:cNvSpPr txBox="1"/>
+          <p:nvPr/>
+        </p:nvSpPr>
+        <p:spPr>
+          <a:xfrm>
+            <a:off x="6507328" y="5486400"/>
+            <a:ext cx="4843120" cy="256032"/>
+          </a:xfrm>
+          <a:prstGeom prst="rect">
+            <a:avLst/>
+          </a:prstGeom>
+          <a:noFill/>
+          <a:ln/>
+        </p:spPr>
+        <p:txBody>
+          <a:bodyPr wrap="square" lIns="0" tIns="0" rIns="0" bIns="0" rtlCol="0" anchor="ctr"/>
+          <a:lstStyle/>
+          <a:p>
+            <a:pPr indent="0" marL="0">
+              <a:buNone/>
+            </a:pPr>
+            <a:r>
+              <a:rPr lang="en-US" sz="1050" dirty="0">
+                <a:solidFill>
+                  <a:srgbClr val="B23A2E"/>
+                </a:solidFill>
+                <a:latin typeface="Calibri" pitchFamily="34" charset="0"/>
+                <a:ea typeface="Calibri" pitchFamily="34" charset="-122"/>
+                <a:cs typeface="Calibri" pitchFamily="34" charset="-120"/>
+              </a:rPr>
+              <a:t>+5 días (+2,7%) · 11 personas</a:t>
+            </a:r>
+            <a:endParaRPr lang="en-US" sz="1050" dirty="0"/>
+          </a:p>
+        </p:txBody>
+      </p:sp>
+      <p:sp>
+        <p:nvSpPr>
+          <p:cNvPr id="32" name="Text 30"/>
+          <p:cNvSpPr txBox="1"/>
+          <p:nvPr/>
+        </p:nvSpPr>
+        <p:spPr>
+          <a:xfrm>
+            <a:off x="6507328" y="5797296"/>
+            <a:ext cx="4843120" cy="566928"/>
           </a:xfrm>
           <a:prstGeom prst="rect">
             <a:avLst/>
@@ -8746,7 +9120,7 @@
               <a:buNone/>
             </a:pPr>
             <a:r>
-              <a:rPr lang="en-US" sz="1300" dirty="0">
+              <a:rPr lang="en-US" sz="1150" dirty="0">
                 <a:solidFill>
                   <a:srgbClr val="2A3B4D"/>
                 </a:solidFill>
@@ -8754,51 +9128,9 @@
                 <a:ea typeface="Calibri" pitchFamily="34" charset="-122"/>
                 <a:cs typeface="Calibri" pitchFamily="34" charset="-120"/>
               </a:rPr>
-              <a:t>Entre 1 y 84 días hábiles. Las de mayor margen son la medición de líneas base (2.4, 84 días) y el diseño del plan de pruebas (7.1, 64 días); la más ajustada es la migración de órdenes abiertas (6.1, 1 día).</a:t>
-            </a:r>
-            <a:endParaRPr lang="en-US" sz="1300" dirty="0"/>
-          </a:p>
-        </p:txBody>
-      </p:sp>
-      <p:sp>
-        <p:nvSpPr>
-          <p:cNvPr id="24" name="Text 22"/>
-          <p:cNvSpPr txBox="1"/>
-          <p:nvPr/>
-        </p:nvSpPr>
-        <p:spPr>
-          <a:xfrm>
-            <a:off x="6507328" y="5276088"/>
-            <a:ext cx="4843120" cy="960120"/>
-          </a:xfrm>
-          <a:prstGeom prst="rect">
-            <a:avLst/>
-          </a:prstGeom>
-          <a:noFill/>
-          <a:ln/>
-        </p:spPr>
-        <p:txBody>
-          <a:bodyPr wrap="square" lIns="0" tIns="0" rIns="0" bIns="0" rtlCol="0" anchor="t"/>
-          <a:lstStyle/>
-          <a:p>
-            <a:pPr indent="0" marL="0">
-              <a:lnSpc>
-                <a:spcPct val="108000"/>
-              </a:lnSpc>
-              <a:buNone/>
-            </a:pPr>
-            <a:r>
-              <a:rPr lang="en-US" sz="1300" dirty="0">
-                <a:solidFill>
-                  <a:srgbClr val="4C6480"/>
-                </a:solidFill>
-                <a:latin typeface="Calibri" pitchFamily="34" charset="0"/>
-                <a:ea typeface="Calibri" pitchFamily="34" charset="-122"/>
-                <a:cs typeface="Calibri" pitchFamily="34" charset="-120"/>
-              </a:rPr>
-              <a:t>Esa holgura es exactamente lo que el aplanamiento consume para resolver los conflictos de recurso sin extender el proyecto.</a:t>
-            </a:r>
-            <a:endParaRPr lang="en-US" sz="1300" dirty="0"/>
+              <a:t>Se adopta la segunda: dos personas parciales cuestan menos que 23 días hábiles adicionales de proyecto, que arrastran licenciamiento, estructura y el diferimiento de los beneficios.</a:t>
+            </a:r>
+            <a:endParaRPr lang="en-US" sz="1150" dirty="0"/>
           </a:p>
         </p:txBody>
       </p:sp>
@@ -8836,7 +9168,7 @@
       </p:grpSpPr>
       <p:pic>
         <p:nvPicPr>
-          <p:cNvPr id="2" name="Image 0" descr="/private/tmp/claude-501/-Users-juanbonadeo-Desktop-UTN/8155766a-ead1-4642-9abc-dd512f5585d8/scratchpad/figs/fig1-red.png">    </p:cNvPr>
+          <p:cNvPr id="2" name="Image 0" descr="/Users/juanbonadeo/Desktop/UTN/materias/ASI/figs/presentacion/fig1-red.png">    </p:cNvPr>
           <p:cNvPicPr>
             <a:picLocks noChangeAspect="1"/>
           </p:cNvPicPr>
@@ -8850,8 +9182,8 @@
         </p:blipFill>
         <p:spPr>
           <a:xfrm>
-            <a:off x="740537" y="173736"/>
-            <a:ext cx="10710622" cy="6510528"/>
+            <a:off x="0" y="0"/>
+            <a:ext cx="12191695" cy="6858000"/>
           </a:xfrm>
           <a:prstGeom prst="rect">
             <a:avLst/>
@@ -8892,7 +9224,7 @@
       </p:grpSpPr>
       <p:pic>
         <p:nvPicPr>
-          <p:cNvPr id="2" name="Image 0" descr="/private/tmp/claude-501/-Users-juanbonadeo-Desktop-UTN/8155766a-ead1-4642-9abc-dd512f5585d8/scratchpad/figs/fig2a-gantt.png">    </p:cNvPr>
+          <p:cNvPr id="2" name="Image 0" descr="/Users/juanbonadeo/Desktop/UTN/materias/ASI/figs/presentacion/fig2a-gantt.png">    </p:cNvPr>
           <p:cNvPicPr>
             <a:picLocks noChangeAspect="1"/>
           </p:cNvPicPr>
@@ -8906,8 +9238,8 @@
         </p:blipFill>
         <p:spPr>
           <a:xfrm>
-            <a:off x="1610248" y="173736"/>
-            <a:ext cx="8971200" cy="6510528"/>
+            <a:off x="0" y="0"/>
+            <a:ext cx="12191695" cy="6858000"/>
           </a:xfrm>
           <a:prstGeom prst="rect">
             <a:avLst/>
@@ -8925,6 +9257,13 @@
 <file path=ppt/slides/slide18.xml><?xml version="1.0" encoding="utf-8"?>
 <p:sld xmlns:a="http://schemas.openxmlformats.org/drawingml/2006/main" xmlns:r="http://schemas.openxmlformats.org/officeDocument/2006/relationships" xmlns:p="http://schemas.openxmlformats.org/presentationml/2006/main">
   <p:cSld name="Slide 18">
+    <p:bg>
+      <p:bgPr>
+        <a:solidFill>
+          <a:srgbClr val="FFFFFF"/>
+        </a:solidFill>
+      </p:bgPr>
+    </p:bg>
     <p:spTree>
       <p:nvGrpSpPr>
         <p:cNvPr id="1" name=""/>
@@ -8939,664 +9278,9 @@
           <a:chExt cx="0" cy="0"/>
         </a:xfrm>
       </p:grpSpPr>
-      <p:sp>
-        <p:nvSpPr>
-          <p:cNvPr id="2" name="Shape 0"/>
-          <p:cNvSpPr/>
-          <p:nvPr/>
-        </p:nvSpPr>
-        <p:spPr>
-          <a:xfrm>
-            <a:off x="566928" y="384048"/>
-            <a:ext cx="566928" cy="566928"/>
-          </a:xfrm>
-          <a:prstGeom prst="ellipse">
-            <a:avLst/>
-          </a:prstGeom>
-          <a:solidFill>
-            <a:srgbClr val="15406B"/>
-          </a:solidFill>
-          <a:ln w="12700">
-            <a:solidFill>
-              <a:srgbClr val="15406B"/>
-            </a:solidFill>
-            <a:prstDash val="solid"/>
-          </a:ln>
-        </p:spPr>
-      </p:sp>
-      <p:sp>
-        <p:nvSpPr>
-          <p:cNvPr id="3" name="Text 1"/>
-          <p:cNvSpPr txBox="1"/>
-          <p:nvPr/>
-        </p:nvSpPr>
-        <p:spPr>
-          <a:xfrm>
-            <a:off x="566928" y="384048"/>
-            <a:ext cx="566928" cy="566928"/>
-          </a:xfrm>
-          <a:prstGeom prst="rect">
-            <a:avLst/>
-          </a:prstGeom>
-          <a:noFill/>
-          <a:ln/>
-        </p:spPr>
-        <p:txBody>
-          <a:bodyPr wrap="square" lIns="0" tIns="0" rIns="0" bIns="0" rtlCol="0" anchor="ctr"/>
-          <a:lstStyle/>
-          <a:p>
-            <a:pPr algn="ctr" indent="0" marL="0">
-              <a:buNone/>
-            </a:pPr>
-            <a:r>
-              <a:rPr lang="en-US" sz="1700" b="1" dirty="0">
-                <a:solidFill>
-                  <a:srgbClr val="FFFFFF"/>
-                </a:solidFill>
-                <a:latin typeface="Calibri" pitchFamily="34" charset="0"/>
-                <a:ea typeface="Calibri" pitchFamily="34" charset="-122"/>
-                <a:cs typeface="Calibri" pitchFamily="34" charset="-120"/>
-              </a:rPr>
-              <a:t>10</a:t>
-            </a:r>
-            <a:endParaRPr lang="en-US" sz="1700" dirty="0"/>
-          </a:p>
-        </p:txBody>
-      </p:sp>
-      <p:sp>
-        <p:nvSpPr>
-          <p:cNvPr id="4" name="Text 2"/>
-          <p:cNvSpPr txBox="1"/>
-          <p:nvPr/>
-        </p:nvSpPr>
-        <p:spPr>
-          <a:xfrm>
-            <a:off x="1353312" y="347472"/>
-            <a:ext cx="10271455" cy="566928"/>
-          </a:xfrm>
-          <a:prstGeom prst="rect">
-            <a:avLst/>
-          </a:prstGeom>
-          <a:noFill/>
-          <a:ln/>
-        </p:spPr>
-        <p:txBody>
-          <a:bodyPr wrap="square" lIns="0" tIns="0" rIns="0" bIns="0" rtlCol="0" anchor="ctr"/>
-          <a:lstStyle/>
-          <a:p>
-            <a:pPr indent="0" marL="0">
-              <a:buNone/>
-            </a:pPr>
-            <a:r>
-              <a:rPr lang="en-US" sz="2900" b="1" dirty="0">
-                <a:solidFill>
-                  <a:srgbClr val="15406B"/>
-                </a:solidFill>
-                <a:latin typeface="Calibri" pitchFamily="34" charset="0"/>
-                <a:ea typeface="Calibri" pitchFamily="34" charset="-122"/>
-                <a:cs typeface="Calibri" pitchFamily="34" charset="-120"/>
-              </a:rPr>
-              <a:t>Aplanamiento de recursos</a:t>
-            </a:r>
-            <a:endParaRPr lang="en-US" sz="2900" dirty="0"/>
-          </a:p>
-        </p:txBody>
-      </p:sp>
-      <p:sp>
-        <p:nvSpPr>
-          <p:cNvPr id="5" name="Text 3"/>
-          <p:cNvSpPr txBox="1"/>
-          <p:nvPr/>
-        </p:nvSpPr>
-        <p:spPr>
-          <a:xfrm>
-            <a:off x="1353312" y="932688"/>
-            <a:ext cx="10271455" cy="475488"/>
-          </a:xfrm>
-          <a:prstGeom prst="rect">
-            <a:avLst/>
-          </a:prstGeom>
-          <a:noFill/>
-          <a:ln/>
-        </p:spPr>
-        <p:txBody>
-          <a:bodyPr wrap="square" lIns="0" tIns="0" rIns="0" bIns="0" rtlCol="0" anchor="t"/>
-          <a:lstStyle/>
-          <a:p>
-            <a:pPr indent="0" marL="0">
-              <a:buNone/>
-            </a:pPr>
-            <a:r>
-              <a:rPr lang="en-US" sz="1250" dirty="0">
-                <a:solidFill>
-                  <a:srgbClr val="4C6480"/>
-                </a:solidFill>
-                <a:latin typeface="Calibri" pitchFamily="34" charset="0"/>
-                <a:ea typeface="Calibri" pitchFamily="34" charset="-122"/>
-                <a:cs typeface="Calibri" pitchFamily="34" charset="-120"/>
-              </a:rPr>
-              <a:t>Seis tramos con dos actividades simultáneas sobre un mismo perfil, detectados contra una dotación de una persona por perfil</a:t>
-            </a:r>
-            <a:endParaRPr lang="en-US" sz="1250" dirty="0"/>
-          </a:p>
-        </p:txBody>
-      </p:sp>
-      <p:sp>
-        <p:nvSpPr>
-          <p:cNvPr id="6" name="Shape 4"/>
-          <p:cNvSpPr/>
-          <p:nvPr/>
-        </p:nvSpPr>
-        <p:spPr>
-          <a:xfrm>
-            <a:off x="566928" y="1517904"/>
-            <a:ext cx="3977640" cy="1133856"/>
-          </a:xfrm>
-          <a:prstGeom prst="roundRect">
-            <a:avLst>
-              <a:gd name="adj" fmla="val 4839"/>
-            </a:avLst>
-          </a:prstGeom>
-          <a:solidFill>
-            <a:srgbClr val="F4F8FC"/>
-          </a:solidFill>
-          <a:ln w="12700">
-            <a:solidFill>
-              <a:srgbClr val="DCE9F7"/>
-            </a:solidFill>
-            <a:prstDash val="solid"/>
-          </a:ln>
-        </p:spPr>
-      </p:sp>
-      <p:sp>
-        <p:nvSpPr>
-          <p:cNvPr id="7" name="Text 5"/>
-          <p:cNvSpPr txBox="1"/>
-          <p:nvPr/>
-        </p:nvSpPr>
-        <p:spPr>
-          <a:xfrm>
-            <a:off x="804672" y="1627632"/>
-            <a:ext cx="3502152" cy="365760"/>
-          </a:xfrm>
-          <a:prstGeom prst="rect">
-            <a:avLst/>
-          </a:prstGeom>
-          <a:noFill/>
-          <a:ln/>
-        </p:spPr>
-        <p:txBody>
-          <a:bodyPr wrap="square" lIns="0" tIns="0" rIns="0" bIns="0" rtlCol="0" anchor="ctr"/>
-          <a:lstStyle/>
-          <a:p>
-            <a:pPr indent="0" marL="0">
-              <a:buNone/>
-            </a:pPr>
-            <a:r>
-              <a:rPr lang="en-US" sz="1250" b="1" dirty="0">
-                <a:solidFill>
-                  <a:srgbClr val="15406B"/>
-                </a:solidFill>
-                <a:latin typeface="Calibri" pitchFamily="34" charset="0"/>
-                <a:ea typeface="Calibri" pitchFamily="34" charset="-122"/>
-                <a:cs typeface="Calibri" pitchFamily="34" charset="-120"/>
-              </a:rPr>
-              <a:t>CPM a fechas tempranas — recursos ilimitados</a:t>
-            </a:r>
-            <a:endParaRPr lang="en-US" sz="1250" dirty="0"/>
-          </a:p>
-        </p:txBody>
-      </p:sp>
-      <p:sp>
-        <p:nvSpPr>
-          <p:cNvPr id="8" name="Text 6"/>
-          <p:cNvSpPr txBox="1"/>
-          <p:nvPr/>
-        </p:nvSpPr>
-        <p:spPr>
-          <a:xfrm>
-            <a:off x="804672" y="2020824"/>
-            <a:ext cx="1417320" cy="512064"/>
-          </a:xfrm>
-          <a:prstGeom prst="rect">
-            <a:avLst/>
-          </a:prstGeom>
-          <a:noFill/>
-          <a:ln/>
-        </p:spPr>
-        <p:txBody>
-          <a:bodyPr wrap="square" lIns="0" tIns="0" rIns="0" bIns="0" rtlCol="0" anchor="ctr"/>
-          <a:lstStyle/>
-          <a:p>
-            <a:pPr indent="0" marL="0">
-              <a:buNone/>
-            </a:pPr>
-            <a:r>
-              <a:rPr lang="en-US" sz="2300" b="1" dirty="0">
-                <a:solidFill>
-                  <a:srgbClr val="4C6480"/>
-                </a:solidFill>
-                <a:latin typeface="Calibri" pitchFamily="34" charset="0"/>
-                <a:ea typeface="Calibri" pitchFamily="34" charset="-122"/>
-                <a:cs typeface="Calibri" pitchFamily="34" charset="-120"/>
-              </a:rPr>
-              <a:t>187 días</a:t>
-            </a:r>
-            <a:endParaRPr lang="en-US" sz="2300" dirty="0"/>
-          </a:p>
-        </p:txBody>
-      </p:sp>
-      <p:sp>
-        <p:nvSpPr>
-          <p:cNvPr id="9" name="Text 7"/>
-          <p:cNvSpPr txBox="1"/>
-          <p:nvPr/>
-        </p:nvSpPr>
-        <p:spPr>
-          <a:xfrm>
-            <a:off x="2267712" y="2020824"/>
-            <a:ext cx="2039112" cy="512064"/>
-          </a:xfrm>
-          <a:prstGeom prst="rect">
-            <a:avLst/>
-          </a:prstGeom>
-          <a:noFill/>
-          <a:ln/>
-        </p:spPr>
-        <p:txBody>
-          <a:bodyPr wrap="square" lIns="0" tIns="0" rIns="0" bIns="0" rtlCol="0" anchor="ctr"/>
-          <a:lstStyle/>
-          <a:p>
-            <a:pPr indent="0" marL="0">
-              <a:buNone/>
-            </a:pPr>
-            <a:r>
-              <a:rPr lang="en-US" sz="1100" dirty="0">
-                <a:solidFill>
-                  <a:srgbClr val="4C6480"/>
-                </a:solidFill>
-                <a:latin typeface="Calibri" pitchFamily="34" charset="0"/>
-                <a:ea typeface="Calibri" pitchFamily="34" charset="-122"/>
-                <a:cs typeface="Calibri" pitchFamily="34" charset="-120"/>
-              </a:rPr>
-              <a:t>Teórica, no ejecutable</a:t>
-            </a:r>
-            <a:endParaRPr lang="en-US" sz="1100" dirty="0"/>
-          </a:p>
-        </p:txBody>
-      </p:sp>
-      <p:sp>
-        <p:nvSpPr>
-          <p:cNvPr id="10" name="Shape 8"/>
-          <p:cNvSpPr/>
-          <p:nvPr/>
-        </p:nvSpPr>
-        <p:spPr>
-          <a:xfrm>
-            <a:off x="566928" y="2779776"/>
-            <a:ext cx="3977640" cy="1133856"/>
-          </a:xfrm>
-          <a:prstGeom prst="roundRect">
-            <a:avLst>
-              <a:gd name="adj" fmla="val 4839"/>
-            </a:avLst>
-          </a:prstGeom>
-          <a:solidFill>
-            <a:srgbClr val="F4F8FC"/>
-          </a:solidFill>
-          <a:ln w="12700">
-            <a:solidFill>
-              <a:srgbClr val="DCE9F7"/>
-            </a:solidFill>
-            <a:prstDash val="solid"/>
-          </a:ln>
-        </p:spPr>
-      </p:sp>
-      <p:sp>
-        <p:nvSpPr>
-          <p:cNvPr id="11" name="Text 9"/>
-          <p:cNvSpPr txBox="1"/>
-          <p:nvPr/>
-        </p:nvSpPr>
-        <p:spPr>
-          <a:xfrm>
-            <a:off x="804672" y="2889504"/>
-            <a:ext cx="3502152" cy="365760"/>
-          </a:xfrm>
-          <a:prstGeom prst="rect">
-            <a:avLst/>
-          </a:prstGeom>
-          <a:noFill/>
-          <a:ln/>
-        </p:spPr>
-        <p:txBody>
-          <a:bodyPr wrap="square" lIns="0" tIns="0" rIns="0" bIns="0" rtlCol="0" anchor="ctr"/>
-          <a:lstStyle/>
-          <a:p>
-            <a:pPr indent="0" marL="0">
-              <a:buNone/>
-            </a:pPr>
-            <a:r>
-              <a:rPr lang="en-US" sz="1250" b="1" dirty="0">
-                <a:solidFill>
-                  <a:srgbClr val="15406B"/>
-                </a:solidFill>
-                <a:latin typeface="Calibri" pitchFamily="34" charset="0"/>
-                <a:ea typeface="Calibri" pitchFamily="34" charset="-122"/>
-                <a:cs typeface="Calibri" pitchFamily="34" charset="-120"/>
-              </a:rPr>
-              <a:t>(a) Nivelación pura — una persona por perfil</a:t>
-            </a:r>
-            <a:endParaRPr lang="en-US" sz="1250" dirty="0"/>
-          </a:p>
-        </p:txBody>
-      </p:sp>
-      <p:sp>
-        <p:nvSpPr>
-          <p:cNvPr id="12" name="Text 10"/>
-          <p:cNvSpPr txBox="1"/>
-          <p:nvPr/>
-        </p:nvSpPr>
-        <p:spPr>
-          <a:xfrm>
-            <a:off x="804672" y="3282696"/>
-            <a:ext cx="1417320" cy="512064"/>
-          </a:xfrm>
-          <a:prstGeom prst="rect">
-            <a:avLst/>
-          </a:prstGeom>
-          <a:noFill/>
-          <a:ln/>
-        </p:spPr>
-        <p:txBody>
-          <a:bodyPr wrap="square" lIns="0" tIns="0" rIns="0" bIns="0" rtlCol="0" anchor="ctr"/>
-          <a:lstStyle/>
-          <a:p>
-            <a:pPr indent="0" marL="0">
-              <a:buNone/>
-            </a:pPr>
-            <a:r>
-              <a:rPr lang="en-US" sz="2300" b="1" dirty="0">
-                <a:solidFill>
-                  <a:srgbClr val="4C6480"/>
-                </a:solidFill>
-                <a:latin typeface="Calibri" pitchFamily="34" charset="0"/>
-                <a:ea typeface="Calibri" pitchFamily="34" charset="-122"/>
-                <a:cs typeface="Calibri" pitchFamily="34" charset="-120"/>
-              </a:rPr>
-              <a:t>215 días</a:t>
-            </a:r>
-            <a:endParaRPr lang="en-US" sz="2300" dirty="0"/>
-          </a:p>
-        </p:txBody>
-      </p:sp>
-      <p:sp>
-        <p:nvSpPr>
-          <p:cNvPr id="13" name="Text 11"/>
-          <p:cNvSpPr txBox="1"/>
-          <p:nvPr/>
-        </p:nvSpPr>
-        <p:spPr>
-          <a:xfrm>
-            <a:off x="2267712" y="3282696"/>
-            <a:ext cx="2039112" cy="512064"/>
-          </a:xfrm>
-          <a:prstGeom prst="rect">
-            <a:avLst/>
-          </a:prstGeom>
-          <a:noFill/>
-          <a:ln/>
-        </p:spPr>
-        <p:txBody>
-          <a:bodyPr wrap="square" lIns="0" tIns="0" rIns="0" bIns="0" rtlCol="0" anchor="ctr"/>
-          <a:lstStyle/>
-          <a:p>
-            <a:pPr indent="0" marL="0">
-              <a:buNone/>
-            </a:pPr>
-            <a:r>
-              <a:rPr lang="en-US" sz="1100" dirty="0">
-                <a:solidFill>
-                  <a:srgbClr val="4C6480"/>
-                </a:solidFill>
-                <a:latin typeface="Calibri" pitchFamily="34" charset="0"/>
-                <a:ea typeface="Calibri" pitchFamily="34" charset="-122"/>
-                <a:cs typeface="Calibri" pitchFamily="34" charset="-120"/>
-              </a:rPr>
-              <a:t>+28 días (+15%) · 9 personas</a:t>
-            </a:r>
-            <a:endParaRPr lang="en-US" sz="1100" dirty="0"/>
-          </a:p>
-        </p:txBody>
-      </p:sp>
-      <p:sp>
-        <p:nvSpPr>
-          <p:cNvPr id="14" name="Shape 12"/>
-          <p:cNvSpPr/>
-          <p:nvPr/>
-        </p:nvSpPr>
-        <p:spPr>
-          <a:xfrm>
-            <a:off x="566928" y="4041648"/>
-            <a:ext cx="3977640" cy="1133856"/>
-          </a:xfrm>
-          <a:prstGeom prst="roundRect">
-            <a:avLst>
-              <a:gd name="adj" fmla="val 4839"/>
-            </a:avLst>
-          </a:prstGeom>
-          <a:solidFill>
-            <a:srgbClr val="DCE9F7"/>
-          </a:solidFill>
-          <a:ln w="12700">
-            <a:solidFill>
-              <a:srgbClr val="5B7FA6"/>
-            </a:solidFill>
-            <a:prstDash val="solid"/>
-          </a:ln>
-        </p:spPr>
-      </p:sp>
-      <p:sp>
-        <p:nvSpPr>
-          <p:cNvPr id="15" name="Text 13"/>
-          <p:cNvSpPr txBox="1"/>
-          <p:nvPr/>
-        </p:nvSpPr>
-        <p:spPr>
-          <a:xfrm>
-            <a:off x="804672" y="4151376"/>
-            <a:ext cx="3502152" cy="365760"/>
-          </a:xfrm>
-          <a:prstGeom prst="rect">
-            <a:avLst/>
-          </a:prstGeom>
-          <a:noFill/>
-          <a:ln/>
-        </p:spPr>
-        <p:txBody>
-          <a:bodyPr wrap="square" lIns="0" tIns="0" rIns="0" bIns="0" rtlCol="0" anchor="ctr"/>
-          <a:lstStyle/>
-          <a:p>
-            <a:pPr indent="0" marL="0">
-              <a:buNone/>
-            </a:pPr>
-            <a:r>
-              <a:rPr lang="en-US" sz="1250" b="1" dirty="0">
-                <a:solidFill>
-                  <a:srgbClr val="15406B"/>
-                </a:solidFill>
-                <a:latin typeface="Calibri" pitchFamily="34" charset="0"/>
-                <a:ea typeface="Calibri" pitchFamily="34" charset="-122"/>
-                <a:cs typeface="Calibri" pitchFamily="34" charset="-120"/>
-              </a:rPr>
-              <a:t>(b) Refuerzo de EI y QA con una persona parcial</a:t>
-            </a:r>
-            <a:endParaRPr lang="en-US" sz="1250" dirty="0"/>
-          </a:p>
-        </p:txBody>
-      </p:sp>
-      <p:sp>
-        <p:nvSpPr>
-          <p:cNvPr id="16" name="Text 14"/>
-          <p:cNvSpPr txBox="1"/>
-          <p:nvPr/>
-        </p:nvSpPr>
-        <p:spPr>
-          <a:xfrm>
-            <a:off x="804672" y="4544568"/>
-            <a:ext cx="1417320" cy="512064"/>
-          </a:xfrm>
-          <a:prstGeom prst="rect">
-            <a:avLst/>
-          </a:prstGeom>
-          <a:noFill/>
-          <a:ln/>
-        </p:spPr>
-        <p:txBody>
-          <a:bodyPr wrap="square" lIns="0" tIns="0" rIns="0" bIns="0" rtlCol="0" anchor="ctr"/>
-          <a:lstStyle/>
-          <a:p>
-            <a:pPr indent="0" marL="0">
-              <a:buNone/>
-            </a:pPr>
-            <a:r>
-              <a:rPr lang="en-US" sz="2300" b="1" dirty="0">
-                <a:solidFill>
-                  <a:srgbClr val="B23A2E"/>
-                </a:solidFill>
-                <a:latin typeface="Calibri" pitchFamily="34" charset="0"/>
-                <a:ea typeface="Calibri" pitchFamily="34" charset="-122"/>
-                <a:cs typeface="Calibri" pitchFamily="34" charset="-120"/>
-              </a:rPr>
-              <a:t>192 días</a:t>
-            </a:r>
-            <a:endParaRPr lang="en-US" sz="2300" dirty="0"/>
-          </a:p>
-        </p:txBody>
-      </p:sp>
-      <p:sp>
-        <p:nvSpPr>
-          <p:cNvPr id="17" name="Text 15"/>
-          <p:cNvSpPr txBox="1"/>
-          <p:nvPr/>
-        </p:nvSpPr>
-        <p:spPr>
-          <a:xfrm>
-            <a:off x="2267712" y="4544568"/>
-            <a:ext cx="1078992" cy="512064"/>
-          </a:xfrm>
-          <a:prstGeom prst="rect">
-            <a:avLst/>
-          </a:prstGeom>
-          <a:noFill/>
-          <a:ln/>
-        </p:spPr>
-        <p:txBody>
-          <a:bodyPr wrap="square" lIns="0" tIns="0" rIns="0" bIns="0" rtlCol="0" anchor="ctr"/>
-          <a:lstStyle/>
-          <a:p>
-            <a:pPr indent="0" marL="0">
-              <a:buNone/>
-            </a:pPr>
-            <a:r>
-              <a:rPr lang="en-US" sz="1100" dirty="0">
-                <a:solidFill>
-                  <a:srgbClr val="4C6480"/>
-                </a:solidFill>
-                <a:latin typeface="Calibri" pitchFamily="34" charset="0"/>
-                <a:ea typeface="Calibri" pitchFamily="34" charset="-122"/>
-                <a:cs typeface="Calibri" pitchFamily="34" charset="-120"/>
-              </a:rPr>
-              <a:t>+5 días · 11 personas</a:t>
-            </a:r>
-            <a:endParaRPr lang="en-US" sz="1100" dirty="0"/>
-          </a:p>
-        </p:txBody>
-      </p:sp>
-      <p:sp>
-        <p:nvSpPr>
-          <p:cNvPr id="18" name="Text 16"/>
-          <p:cNvSpPr txBox="1"/>
-          <p:nvPr/>
-        </p:nvSpPr>
-        <p:spPr>
-          <a:xfrm>
-            <a:off x="3401568" y="4544568"/>
-            <a:ext cx="914400" cy="512064"/>
-          </a:xfrm>
-          <a:prstGeom prst="rect">
-            <a:avLst/>
-          </a:prstGeom>
-          <a:noFill/>
-          <a:ln/>
-        </p:spPr>
-        <p:txBody>
-          <a:bodyPr wrap="square" lIns="0" tIns="0" rIns="0" bIns="0" rtlCol="0" anchor="ctr"/>
-          <a:lstStyle/>
-          <a:p>
-            <a:pPr algn="r" indent="0" marL="0">
-              <a:buNone/>
-            </a:pPr>
-            <a:r>
-              <a:rPr lang="en-US" sz="1050" b="1" dirty="0">
-                <a:solidFill>
-                  <a:srgbClr val="B23A2E"/>
-                </a:solidFill>
-                <a:latin typeface="Calibri" pitchFamily="34" charset="0"/>
-                <a:ea typeface="Calibri" pitchFamily="34" charset="-122"/>
-                <a:cs typeface="Calibri" pitchFamily="34" charset="-120"/>
-              </a:rPr>
-              <a:t>ADOPTADA</a:t>
-            </a:r>
-            <a:endParaRPr lang="en-US" sz="1050" dirty="0"/>
-          </a:p>
-        </p:txBody>
-      </p:sp>
-      <p:sp>
-        <p:nvSpPr>
-          <p:cNvPr id="19" name="Text 17"/>
-          <p:cNvSpPr txBox="1"/>
-          <p:nvPr/>
-        </p:nvSpPr>
-        <p:spPr>
-          <a:xfrm>
-            <a:off x="566928" y="5394960"/>
-            <a:ext cx="3977640" cy="1737360"/>
-          </a:xfrm>
-          <a:prstGeom prst="rect">
-            <a:avLst/>
-          </a:prstGeom>
-          <a:noFill/>
-          <a:ln/>
-        </p:spPr>
-        <p:txBody>
-          <a:bodyPr wrap="square" lIns="0" tIns="0" rIns="0" bIns="0" rtlCol="0" anchor="t"/>
-          <a:lstStyle/>
-          <a:p>
-            <a:pPr indent="0" marL="0">
-              <a:lnSpc>
-                <a:spcPct val="108000"/>
-              </a:lnSpc>
-              <a:buNone/>
-            </a:pPr>
-            <a:r>
-              <a:rPr lang="en-US" sz="1250" dirty="0">
-                <a:solidFill>
-                  <a:srgbClr val="2A3B4D"/>
-                </a:solidFill>
-                <a:latin typeface="Calibri" pitchFamily="34" charset="0"/>
-                <a:ea typeface="Calibri" pitchFamily="34" charset="-122"/>
-                <a:cs typeface="Calibri" pitchFamily="34" charset="-120"/>
-              </a:rPr>
-              <a:t>El fundamento es económico: dos personas parciales durante ventanas acotadas cuestan menos que 23 días hábiles adicionales de proyecto, que arrastran licenciamiento, estructura y el diferimiento de todos los beneficios. Los conflictos que el refuerzo no elimina se resuelven corriendo 24 actividades dentro de su holgura.</a:t>
-            </a:r>
-            <a:endParaRPr lang="en-US" sz="1250" dirty="0"/>
-          </a:p>
-        </p:txBody>
-      </p:sp>
       <p:pic>
         <p:nvPicPr>
-          <p:cNvPr id="20" name="Image 0" descr="/private/tmp/claude-501/-Users-juanbonadeo-Desktop-UTN/8155766a-ead1-4642-9abc-dd512f5585d8/scratchpad/figs/fig2b-histo.png">    </p:cNvPr>
+          <p:cNvPr id="2" name="Image 0" descr="/Users/juanbonadeo/Desktop/UTN/materias/ASI/figs/presentacion/fig2b-histo.png">    </p:cNvPr>
           <p:cNvPicPr>
             <a:picLocks noChangeAspect="1"/>
           </p:cNvPicPr>
@@ -9610,53 +9294,14 @@
         </p:blipFill>
         <p:spPr>
           <a:xfrm>
-            <a:off x="4855464" y="1463040"/>
-            <a:ext cx="6769303" cy="4719171"/>
+            <a:off x="0" y="0"/>
+            <a:ext cx="12191695" cy="6858000"/>
           </a:xfrm>
           <a:prstGeom prst="rect">
             <a:avLst/>
           </a:prstGeom>
         </p:spPr>
       </p:pic>
-      <p:sp>
-        <p:nvSpPr>
-          <p:cNvPr id="21" name="Text 18"/>
-          <p:cNvSpPr txBox="1"/>
-          <p:nvPr/>
-        </p:nvSpPr>
-        <p:spPr>
-          <a:xfrm>
-            <a:off x="4855464" y="6273651"/>
-            <a:ext cx="6769303" cy="274320"/>
-          </a:xfrm>
-          <a:prstGeom prst="rect">
-            <a:avLst/>
-          </a:prstGeom>
-          <a:noFill/>
-          <a:ln/>
-        </p:spPr>
-        <p:txBody>
-          <a:bodyPr wrap="square" lIns="0" tIns="0" rIns="0" bIns="0" rtlCol="0" anchor="ctr"/>
-          <a:lstStyle/>
-          <a:p>
-            <a:pPr indent="0" marL="0">
-              <a:buNone/>
-            </a:pPr>
-            <a:r>
-              <a:rPr lang="en-US" sz="1050" i="1" dirty="0">
-                <a:solidFill>
-                  <a:srgbClr val="4C6480"/>
-                </a:solidFill>
-                <a:latin typeface="Calibri" pitchFamily="34" charset="0"/>
-                <a:ea typeface="Calibri" pitchFamily="34" charset="-122"/>
-                <a:cs typeface="Calibri" pitchFamily="34" charset="-120"/>
-              </a:rPr>
-              <a:t>Figura 2.b del Anexo II — histograma de recursos por perfil, sobre el mismo eje de tiempo y a la misma escala que el Gantt</a:t>
-            </a:r>
-            <a:endParaRPr lang="en-US" sz="1050" dirty="0"/>
-          </a:p>
-        </p:txBody>
-      </p:sp>
     </p:spTree>
   </p:cSld>
   <p:clrMapOvr>

</xml_diff>